<commit_message>
Slides: fourth concept on sd-05-003 cover; ByteByteGo back on sd-05-004 sources
Co-Authored-By: Claude Opus 5.5 <noreply@anthropic.com>
Claude-Session: https://claude.ai/code/session_01C9pH8NnezrynRr5dznPeP3
</commit_message>
<xml_diff>
--- a/system-design-101/vi/lessons/sd-05-003/slides/sd-05-003.pptx
+++ b/system-design-101/vi/lessons/sd-05-003/slides/sd-05-003.pptx
@@ -2941,7 +2941,145 @@
       </p:sp>
       <p:sp>
         <p:nvSpPr>
-          <p:cNvPr id="24" name="Shape 22"/>
+          <p:cNvPr id="24" name="Text 22"/>
+          <p:cNvSpPr/>
+          <p:nvPr/>
+        </p:nvSpPr>
+        <p:spPr>
+          <a:xfrm>
+            <a:off x="14725650" y="5524500"/>
+            <a:ext cx="2647950" cy="342900"/>
+          </a:xfrm>
+          <a:prstGeom prst="rect">
+            <a:avLst/>
+          </a:prstGeom>
+          <a:noFill/>
+          <a:ln/>
+        </p:spPr>
+        <p:txBody>
+          <a:bodyPr wrap="square" lIns="0" tIns="0" rIns="0" bIns="0" rtlCol="0" anchor="t"/>
+          <a:lstStyle/>
+          <a:p>
+            <a:pPr algn="ctr" indent="0" marL="0">
+              <a:buNone/>
+            </a:pPr>
+            <a:r>
+              <a:rPr lang="en-US" sz="1800" b="1" spc="142" kern="0" dirty="0">
+                <a:solidFill>
+                  <a:srgbClr val="9AA0B5"/>
+                </a:solidFill>
+                <a:latin typeface="Be Vietnam Pro" pitchFamily="34" charset="0"/>
+                <a:ea typeface="Be Vietnam Pro" pitchFamily="34" charset="-122"/>
+                <a:cs typeface="Be Vietnam Pro" pitchFamily="34" charset="-120"/>
+              </a:rPr>
+              <a:t>thông</a:t>
+            </a:r>
+            <a:r>
+              <a:rPr lang="en-US" sz="1800" b="1" spc="159" kern="0" dirty="0">
+                <a:solidFill>
+                  <a:srgbClr val="9AA0B5"/>
+                </a:solidFill>
+                <a:latin typeface="Be Vietnam Pro" pitchFamily="34" charset="0"/>
+                <a:ea typeface="Be Vietnam Pro" pitchFamily="34" charset="-122"/>
+                <a:cs typeface="Be Vietnam Pro" pitchFamily="34" charset="-120"/>
+              </a:rPr>
+              <a:t> điệp</a:t>
+            </a:r>
+            <a:endParaRPr lang="en-US" sz="1800" dirty="0"/>
+          </a:p>
+        </p:txBody>
+      </p:sp>
+      <p:sp>
+        <p:nvSpPr>
+          <p:cNvPr id="25" name="Shape 23"/>
+          <p:cNvSpPr/>
+          <p:nvPr/>
+        </p:nvSpPr>
+        <p:spPr>
+          <a:xfrm>
+            <a:off x="14725650" y="5953125"/>
+            <a:ext cx="2647950" cy="914400"/>
+          </a:xfrm>
+          <a:prstGeom prst="roundRect">
+            <a:avLst>
+              <a:gd name="adj" fmla="val 20833"/>
+            </a:avLst>
+          </a:prstGeom>
+          <a:solidFill>
+            <a:srgbClr val="1E212B"/>
+          </a:solidFill>
+          <a:ln w="28575">
+            <a:solidFill>
+              <a:srgbClr val="3DD6A0"/>
+            </a:solidFill>
+            <a:prstDash val="solid"/>
+          </a:ln>
+        </p:spPr>
+      </p:sp>
+      <p:sp>
+        <p:nvSpPr>
+          <p:cNvPr id="26" name="Text 24"/>
+          <p:cNvSpPr/>
+          <p:nvPr/>
+        </p:nvSpPr>
+        <p:spPr>
+          <a:xfrm>
+            <a:off x="14820900" y="5953125"/>
+            <a:ext cx="2457450" cy="914400"/>
+          </a:xfrm>
+          <a:prstGeom prst="rect">
+            <a:avLst/>
+          </a:prstGeom>
+          <a:noFill/>
+          <a:ln/>
+        </p:spPr>
+        <p:txBody>
+          <a:bodyPr wrap="square" lIns="0" tIns="0" rIns="0" bIns="0" rtlCol="0" anchor="ctr"/>
+          <a:lstStyle/>
+          <a:p>
+            <a:pPr algn="ctr" indent="0" marL="0">
+              <a:buNone/>
+            </a:pPr>
+            <a:r>
+              <a:rPr lang="en-US" sz="2100" b="1" dirty="0" spc="-10" kern="0">
+                <a:solidFill>
+                  <a:srgbClr val="3DD6A0"/>
+                </a:solidFill>
+                <a:latin typeface="Be Vietnam Pro" pitchFamily="34" charset="0"/>
+                <a:ea typeface="Be Vietnam Pro" pitchFamily="34" charset="-122"/>
+                <a:cs typeface="Be Vietnam Pro" pitchFamily="34" charset="-120"/>
+              </a:rPr>
+              <a:t>dòng</a:t>
+            </a:r>
+            <a:r>
+              <a:rPr lang="en-US" sz="2100" b="1" dirty="0" spc="7" kern="0">
+                <a:solidFill>
+                  <a:srgbClr val="3DD6A0"/>
+                </a:solidFill>
+                <a:latin typeface="Be Vietnam Pro" pitchFamily="34" charset="0"/>
+                <a:ea typeface="Be Vietnam Pro" pitchFamily="34" charset="-122"/>
+                <a:cs typeface="Be Vietnam Pro" pitchFamily="34" charset="-120"/>
+              </a:rPr>
+              <a:t> đầu</a:t>
+            </a:r>
+            <a:r>
+              <a:rPr lang="en-US" sz="2100" b="1" dirty="0" spc="-5" kern="0">
+                <a:solidFill>
+                  <a:srgbClr val="3DD6A0"/>
+                </a:solidFill>
+                <a:latin typeface="Be Vietnam Pro" pitchFamily="34" charset="0"/>
+                <a:ea typeface="Be Vietnam Pro" pitchFamily="34" charset="-122"/>
+                <a:cs typeface="Be Vietnam Pro" pitchFamily="34" charset="-120"/>
+              </a:rPr>
+              <a:t> + header</a:t>
+            </a:r>
+            <a:endParaRPr lang="en-US" sz="2100" dirty="0"/>
+          </a:p>
+        </p:txBody>
+      </p:sp>
+      <p:sp>
+        <p:nvSpPr>
+          <p:cNvPr id="27" name="Shape 25"/>
           <p:cNvSpPr/>
           <p:nvPr/>
         </p:nvSpPr>
@@ -2965,7 +3103,7 @@
       </p:sp>
       <p:pic>
         <p:nvPicPr>
-          <p:cNvPr id="25" name="Moda image moda-export-watermark-cf3e5613-fad0-4a95-b907-2c5d8a98c7d3" descr="">    </p:cNvPr>
+          <p:cNvPr id="28" name="Moda image moda-export-watermark-cf3e5613-fad0-4a95-b907-2c5d8a98c7d3" descr="">    </p:cNvPr>
           <p:cNvPicPr>
             <a:picLocks noChangeAspect="1"/>
           </p:cNvPicPr>

</xml_diff>